<commit_message>
Add demo video narration script and keep commit count on slides current
</commit_message>
<xml_diff>
--- a/ClinicFlow-Presentation.pptx
+++ b/ClinicFlow-Presentation.pptx
@@ -124,14 +124,14 @@
   <p:extLst>
     <p:ext uri="{521415D9-36F7-43E2-AB2F-B90AF26B5E84}">
       <p14:sectionLst xmlns:p14="http://schemas.microsoft.com/office/powerpoint/2010/main">
-        <p14:section name="Introduction" id="{d2573e9d-6120-52f7-a677-34a58aec639c}">
+        <p14:section name="Introduction" id="{c6278a93-2b4e-4933-d425-35930f9e70d7}">
           <p14:sldIdLst>
             <p14:sldId id="256"/>
             <p14:sldId id="257"/>
             <p14:sldId id="258"/>
           </p14:sldIdLst>
         </p14:section>
-        <p14:section name="Pipeline stages" id="{4ebb8eb7-6e1f-f216-083d-00ce3c2d3d1e}">
+        <p14:section name="Pipeline stages" id="{ff2a0861-d179-0788-31a9-cf70dcab71e4}">
           <p14:sldIdLst>
             <p14:sldId id="259"/>
             <p14:sldId id="260"/>
@@ -148,7 +148,7 @@
             <p14:sldId id="271"/>
           </p14:sldIdLst>
         </p14:section>
-        <p14:section name="Wrap-up" id="{caa6b396-8011-e9e0-fa18-c8a642f11136}">
+        <p14:section name="Wrap-up" id="{564401d6-a3fd-865b-1bd7-45b5cc47f08c}">
           <p14:sldIdLst>
             <p14:sldId id="272"/>
             <p14:sldId id="273"/>
@@ -14137,7 +14137,7 @@
                 <a:ea typeface="+mn-lt" pitchFamily="34" charset="-122"/>
                 <a:cs typeface="+mn-lt" pitchFamily="34" charset="-120"/>
               </a:rPr>
-              <a:t>20 commits: each one does one logical thing</a:t>
+              <a:t>20+ commits, each doing one logical thing</a:t>
             </a:r>
             <a:endParaRPr lang="en-US" sz="1700" dirty="0"/>
           </a:p>
@@ -14443,7 +14443,7 @@
                 <a:ea typeface="Courier New" pitchFamily="34" charset="-122"/>
                 <a:cs typeface="Courier New" pitchFamily="34" charset="-120"/>
               </a:rPr>
-              <a:t>... 20 commits total</a:t>
+              <a:t>... 20+ commits</a:t>
             </a:r>
             <a:endParaRPr lang="en-US" sz="1300" dirty="0"/>
           </a:p>

</xml_diff>